<commit_message>
investment add and generating balances fun create
</commit_message>
<xml_diff>
--- a/balance_generate/plan_projektu_bank.pptx
+++ b/balance_generate/plan_projektu_bank.pptx
@@ -7,6 +7,8 @@
   <p:sldIdLst>
     <p:sldId id="256" r:id="rId2"/>
     <p:sldId id="257" r:id="rId3"/>
+    <p:sldId id="258" r:id="rId4"/>
+    <p:sldId id="259" r:id="rId5"/>
   </p:sldIdLst>
   <p:sldSz cx="12192000" cy="6858000"/>
   <p:notesSz cx="6858000" cy="9144000"/>
@@ -105,6 +107,11 @@
       </a:defRPr>
     </a:lvl9pPr>
   </p:defaultTextStyle>
+  <p:extLst>
+    <p:ext uri="{EFAFB233-063F-42B5-8137-9DF3F51BA10A}">
+      <p15:sldGuideLst xmlns:p15="http://schemas.microsoft.com/office/powerpoint/2012/main"/>
+    </p:ext>
+  </p:extLst>
 </p:presentation>
 </file>
 
@@ -257,7 +264,7 @@
           <a:p>
             <a:fld id="{96BE46AA-D6DA-4CA4-8297-EAFC65485042}" type="datetimeFigureOut">
               <a:rPr lang="pl-PL" smtClean="0"/>
-              <a:t>31.07.2025</a:t>
+              <a:t>4.08.2025</a:t>
             </a:fld>
             <a:endParaRPr lang="pl-PL"/>
           </a:p>
@@ -457,7 +464,7 @@
           <a:p>
             <a:fld id="{96BE46AA-D6DA-4CA4-8297-EAFC65485042}" type="datetimeFigureOut">
               <a:rPr lang="pl-PL" smtClean="0"/>
-              <a:t>31.07.2025</a:t>
+              <a:t>4.08.2025</a:t>
             </a:fld>
             <a:endParaRPr lang="pl-PL"/>
           </a:p>
@@ -667,7 +674,7 @@
           <a:p>
             <a:fld id="{96BE46AA-D6DA-4CA4-8297-EAFC65485042}" type="datetimeFigureOut">
               <a:rPr lang="pl-PL" smtClean="0"/>
-              <a:t>31.07.2025</a:t>
+              <a:t>4.08.2025</a:t>
             </a:fld>
             <a:endParaRPr lang="pl-PL"/>
           </a:p>
@@ -867,7 +874,7 @@
           <a:p>
             <a:fld id="{96BE46AA-D6DA-4CA4-8297-EAFC65485042}" type="datetimeFigureOut">
               <a:rPr lang="pl-PL" smtClean="0"/>
-              <a:t>31.07.2025</a:t>
+              <a:t>4.08.2025</a:t>
             </a:fld>
             <a:endParaRPr lang="pl-PL"/>
           </a:p>
@@ -1143,7 +1150,7 @@
           <a:p>
             <a:fld id="{96BE46AA-D6DA-4CA4-8297-EAFC65485042}" type="datetimeFigureOut">
               <a:rPr lang="pl-PL" smtClean="0"/>
-              <a:t>31.07.2025</a:t>
+              <a:t>4.08.2025</a:t>
             </a:fld>
             <a:endParaRPr lang="pl-PL"/>
           </a:p>
@@ -1411,7 +1418,7 @@
           <a:p>
             <a:fld id="{96BE46AA-D6DA-4CA4-8297-EAFC65485042}" type="datetimeFigureOut">
               <a:rPr lang="pl-PL" smtClean="0"/>
-              <a:t>31.07.2025</a:t>
+              <a:t>4.08.2025</a:t>
             </a:fld>
             <a:endParaRPr lang="pl-PL"/>
           </a:p>
@@ -1826,7 +1833,7 @@
           <a:p>
             <a:fld id="{96BE46AA-D6DA-4CA4-8297-EAFC65485042}" type="datetimeFigureOut">
               <a:rPr lang="pl-PL" smtClean="0"/>
-              <a:t>31.07.2025</a:t>
+              <a:t>4.08.2025</a:t>
             </a:fld>
             <a:endParaRPr lang="pl-PL"/>
           </a:p>
@@ -1968,7 +1975,7 @@
           <a:p>
             <a:fld id="{96BE46AA-D6DA-4CA4-8297-EAFC65485042}" type="datetimeFigureOut">
               <a:rPr lang="pl-PL" smtClean="0"/>
-              <a:t>31.07.2025</a:t>
+              <a:t>4.08.2025</a:t>
             </a:fld>
             <a:endParaRPr lang="pl-PL"/>
           </a:p>
@@ -2081,7 +2088,7 @@
           <a:p>
             <a:fld id="{96BE46AA-D6DA-4CA4-8297-EAFC65485042}" type="datetimeFigureOut">
               <a:rPr lang="pl-PL" smtClean="0"/>
-              <a:t>31.07.2025</a:t>
+              <a:t>4.08.2025</a:t>
             </a:fld>
             <a:endParaRPr lang="pl-PL"/>
           </a:p>
@@ -2394,7 +2401,7 @@
           <a:p>
             <a:fld id="{96BE46AA-D6DA-4CA4-8297-EAFC65485042}" type="datetimeFigureOut">
               <a:rPr lang="pl-PL" smtClean="0"/>
-              <a:t>31.07.2025</a:t>
+              <a:t>4.08.2025</a:t>
             </a:fld>
             <a:endParaRPr lang="pl-PL"/>
           </a:p>
@@ -2683,7 +2690,7 @@
           <a:p>
             <a:fld id="{96BE46AA-D6DA-4CA4-8297-EAFC65485042}" type="datetimeFigureOut">
               <a:rPr lang="pl-PL" smtClean="0"/>
-              <a:t>31.07.2025</a:t>
+              <a:t>4.08.2025</a:t>
             </a:fld>
             <a:endParaRPr lang="pl-PL"/>
           </a:p>
@@ -2926,7 +2933,7 @@
           <a:p>
             <a:fld id="{96BE46AA-D6DA-4CA4-8297-EAFC65485042}" type="datetimeFigureOut">
               <a:rPr lang="pl-PL" smtClean="0"/>
-              <a:t>31.07.2025</a:t>
+              <a:t>4.08.2025</a:t>
             </a:fld>
             <a:endParaRPr lang="pl-PL"/>
           </a:p>
@@ -3806,6 +3813,2130 @@
     <p:extLst>
       <p:ext uri="{BB962C8B-B14F-4D97-AF65-F5344CB8AC3E}">
         <p14:creationId xmlns:p14="http://schemas.microsoft.com/office/powerpoint/2010/main" val="2389126920"/>
+      </p:ext>
+    </p:extLst>
+  </p:cSld>
+  <p:clrMapOvr>
+    <a:masterClrMapping/>
+  </p:clrMapOvr>
+</p:sld>
+</file>
+
+<file path=ppt/slides/slide3.xml><?xml version="1.0" encoding="utf-8"?>
+<p:sld xmlns:a="http://schemas.openxmlformats.org/drawingml/2006/main" xmlns:r="http://schemas.openxmlformats.org/officeDocument/2006/relationships" xmlns:p="http://schemas.openxmlformats.org/presentationml/2006/main">
+  <p:cSld>
+    <p:spTree>
+      <p:nvGrpSpPr>
+        <p:cNvPr id="1" name=""/>
+        <p:cNvGrpSpPr/>
+        <p:nvPr/>
+      </p:nvGrpSpPr>
+      <p:grpSpPr>
+        <a:xfrm>
+          <a:off x="0" y="0"/>
+          <a:ext cx="0" cy="0"/>
+          <a:chOff x="0" y="0"/>
+          <a:chExt cx="0" cy="0"/>
+        </a:xfrm>
+      </p:grpSpPr>
+      <p:sp>
+        <p:nvSpPr>
+          <p:cNvPr id="2" name="Title 1">
+            <a:extLst>
+              <a:ext uri="{FF2B5EF4-FFF2-40B4-BE49-F238E27FC236}">
+                <a16:creationId xmlns:a16="http://schemas.microsoft.com/office/drawing/2014/main" id="{5BCDAB6C-4676-D5C8-B03E-294094252E98}"/>
+              </a:ext>
+            </a:extLst>
+          </p:cNvPr>
+          <p:cNvSpPr>
+            <a:spLocks noGrp="1"/>
+          </p:cNvSpPr>
+          <p:nvPr>
+            <p:ph type="title"/>
+          </p:nvPr>
+        </p:nvSpPr>
+        <p:spPr/>
+        <p:txBody>
+          <a:bodyPr/>
+          <a:lstStyle/>
+          <a:p>
+            <a:r>
+              <a:rPr lang="pl-PL" dirty="0" err="1"/>
+              <a:t>Phase</a:t>
+            </a:r>
+            <a:r>
+              <a:rPr lang="pl-PL" dirty="0"/>
+              <a:t> 0 -  SQL </a:t>
+            </a:r>
+            <a:r>
+              <a:rPr lang="pl-PL" dirty="0" err="1"/>
+              <a:t>schema</a:t>
+            </a:r>
+            <a:r>
+              <a:rPr lang="pl-PL" dirty="0"/>
+              <a:t> </a:t>
+            </a:r>
+          </a:p>
+        </p:txBody>
+      </p:sp>
+      <p:sp>
+        <p:nvSpPr>
+          <p:cNvPr id="4" name="Rectangle 3">
+            <a:extLst>
+              <a:ext uri="{FF2B5EF4-FFF2-40B4-BE49-F238E27FC236}">
+                <a16:creationId xmlns:a16="http://schemas.microsoft.com/office/drawing/2014/main" id="{EE848EEF-DB1B-3AA2-9750-0CA8A343F2AA}"/>
+              </a:ext>
+            </a:extLst>
+          </p:cNvPr>
+          <p:cNvSpPr/>
+          <p:nvPr/>
+        </p:nvSpPr>
+        <p:spPr>
+          <a:xfrm>
+            <a:off x="5406620" y="3093004"/>
+            <a:ext cx="1650830" cy="521638"/>
+          </a:xfrm>
+          <a:prstGeom prst="rect">
+            <a:avLst/>
+          </a:prstGeom>
+        </p:spPr>
+        <p:style>
+          <a:lnRef idx="2">
+            <a:schemeClr val="accent1">
+              <a:shade val="15000"/>
+            </a:schemeClr>
+          </a:lnRef>
+          <a:fillRef idx="1">
+            <a:schemeClr val="accent1"/>
+          </a:fillRef>
+          <a:effectRef idx="0">
+            <a:schemeClr val="accent1"/>
+          </a:effectRef>
+          <a:fontRef idx="minor">
+            <a:schemeClr val="lt1"/>
+          </a:fontRef>
+        </p:style>
+        <p:txBody>
+          <a:bodyPr rtlCol="0" anchor="ctr"/>
+          <a:lstStyle/>
+          <a:p>
+            <a:pPr algn="ctr"/>
+            <a:r>
+              <a:rPr lang="pl-PL" dirty="0" err="1"/>
+              <a:t>transactions</a:t>
+            </a:r>
+            <a:endParaRPr lang="pl-PL" dirty="0"/>
+          </a:p>
+        </p:txBody>
+      </p:sp>
+      <p:cxnSp>
+        <p:nvCxnSpPr>
+          <p:cNvPr id="6" name="Straight Arrow Connector 5">
+            <a:extLst>
+              <a:ext uri="{FF2B5EF4-FFF2-40B4-BE49-F238E27FC236}">
+                <a16:creationId xmlns:a16="http://schemas.microsoft.com/office/drawing/2014/main" id="{438E0FD9-84C9-850C-F14A-2FCE4586239C}"/>
+              </a:ext>
+            </a:extLst>
+          </p:cNvPr>
+          <p:cNvCxnSpPr>
+            <a:stCxn id="4" idx="0"/>
+          </p:cNvCxnSpPr>
+          <p:nvPr/>
+        </p:nvCxnSpPr>
+        <p:spPr>
+          <a:xfrm flipH="1" flipV="1">
+            <a:off x="6222830" y="2233836"/>
+            <a:ext cx="9205" cy="859168"/>
+          </a:xfrm>
+          <a:prstGeom prst="straightConnector1">
+            <a:avLst/>
+          </a:prstGeom>
+          <a:ln>
+            <a:tailEnd type="triangle"/>
+          </a:ln>
+        </p:spPr>
+        <p:style>
+          <a:lnRef idx="2">
+            <a:schemeClr val="accent1"/>
+          </a:lnRef>
+          <a:fillRef idx="0">
+            <a:schemeClr val="accent1"/>
+          </a:fillRef>
+          <a:effectRef idx="1">
+            <a:schemeClr val="accent1"/>
+          </a:effectRef>
+          <a:fontRef idx="minor">
+            <a:schemeClr val="tx1"/>
+          </a:fontRef>
+        </p:style>
+      </p:cxnSp>
+      <p:cxnSp>
+        <p:nvCxnSpPr>
+          <p:cNvPr id="7" name="Straight Arrow Connector 6">
+            <a:extLst>
+              <a:ext uri="{FF2B5EF4-FFF2-40B4-BE49-F238E27FC236}">
+                <a16:creationId xmlns:a16="http://schemas.microsoft.com/office/drawing/2014/main" id="{DCA2988F-CE8A-92EC-F632-7E30C5E4986F}"/>
+              </a:ext>
+            </a:extLst>
+          </p:cNvPr>
+          <p:cNvCxnSpPr>
+            <a:cxnSpLocks/>
+          </p:cNvCxnSpPr>
+          <p:nvPr/>
+        </p:nvCxnSpPr>
+        <p:spPr>
+          <a:xfrm flipH="1" flipV="1">
+            <a:off x="4602685" y="2843436"/>
+            <a:ext cx="813140" cy="257719"/>
+          </a:xfrm>
+          <a:prstGeom prst="straightConnector1">
+            <a:avLst/>
+          </a:prstGeom>
+          <a:ln>
+            <a:tailEnd type="triangle"/>
+          </a:ln>
+        </p:spPr>
+        <p:style>
+          <a:lnRef idx="2">
+            <a:schemeClr val="accent1"/>
+          </a:lnRef>
+          <a:fillRef idx="0">
+            <a:schemeClr val="accent1"/>
+          </a:fillRef>
+          <a:effectRef idx="1">
+            <a:schemeClr val="accent1"/>
+          </a:effectRef>
+          <a:fontRef idx="minor">
+            <a:schemeClr val="tx1"/>
+          </a:fontRef>
+        </p:style>
+      </p:cxnSp>
+      <p:cxnSp>
+        <p:nvCxnSpPr>
+          <p:cNvPr id="8" name="Straight Arrow Connector 7">
+            <a:extLst>
+              <a:ext uri="{FF2B5EF4-FFF2-40B4-BE49-F238E27FC236}">
+                <a16:creationId xmlns:a16="http://schemas.microsoft.com/office/drawing/2014/main" id="{63CE23C8-B6A9-42D2-B6E7-39259EAA6CDF}"/>
+              </a:ext>
+            </a:extLst>
+          </p:cNvPr>
+          <p:cNvCxnSpPr>
+            <a:cxnSpLocks/>
+            <a:endCxn id="34" idx="3"/>
+          </p:cNvCxnSpPr>
+          <p:nvPr/>
+        </p:nvCxnSpPr>
+        <p:spPr>
+          <a:xfrm flipH="1">
+            <a:off x="4763205" y="3120508"/>
+            <a:ext cx="859550" cy="1133395"/>
+          </a:xfrm>
+          <a:prstGeom prst="straightConnector1">
+            <a:avLst/>
+          </a:prstGeom>
+          <a:ln>
+            <a:tailEnd type="triangle"/>
+          </a:ln>
+        </p:spPr>
+        <p:style>
+          <a:lnRef idx="2">
+            <a:schemeClr val="accent1"/>
+          </a:lnRef>
+          <a:fillRef idx="0">
+            <a:schemeClr val="accent1"/>
+          </a:fillRef>
+          <a:effectRef idx="1">
+            <a:schemeClr val="accent1"/>
+          </a:effectRef>
+          <a:fontRef idx="minor">
+            <a:schemeClr val="tx1"/>
+          </a:fontRef>
+        </p:style>
+      </p:cxnSp>
+      <p:cxnSp>
+        <p:nvCxnSpPr>
+          <p:cNvPr id="10" name="Straight Arrow Connector 9">
+            <a:extLst>
+              <a:ext uri="{FF2B5EF4-FFF2-40B4-BE49-F238E27FC236}">
+                <a16:creationId xmlns:a16="http://schemas.microsoft.com/office/drawing/2014/main" id="{D4779765-01AA-CF28-D881-CE2F7A9BB520}"/>
+              </a:ext>
+            </a:extLst>
+          </p:cNvPr>
+          <p:cNvCxnSpPr>
+            <a:cxnSpLocks/>
+            <a:endCxn id="39" idx="0"/>
+          </p:cNvCxnSpPr>
+          <p:nvPr/>
+        </p:nvCxnSpPr>
+        <p:spPr>
+          <a:xfrm>
+            <a:off x="6480580" y="3614642"/>
+            <a:ext cx="1086235" cy="1402316"/>
+          </a:xfrm>
+          <a:prstGeom prst="straightConnector1">
+            <a:avLst/>
+          </a:prstGeom>
+          <a:ln>
+            <a:tailEnd type="triangle"/>
+          </a:ln>
+        </p:spPr>
+        <p:style>
+          <a:lnRef idx="2">
+            <a:schemeClr val="accent1"/>
+          </a:lnRef>
+          <a:fillRef idx="0">
+            <a:schemeClr val="accent1"/>
+          </a:fillRef>
+          <a:effectRef idx="1">
+            <a:schemeClr val="accent1"/>
+          </a:effectRef>
+          <a:fontRef idx="minor">
+            <a:schemeClr val="tx1"/>
+          </a:fontRef>
+        </p:style>
+      </p:cxnSp>
+      <p:cxnSp>
+        <p:nvCxnSpPr>
+          <p:cNvPr id="11" name="Straight Arrow Connector 10">
+            <a:extLst>
+              <a:ext uri="{FF2B5EF4-FFF2-40B4-BE49-F238E27FC236}">
+                <a16:creationId xmlns:a16="http://schemas.microsoft.com/office/drawing/2014/main" id="{868C8802-E7DB-B3AF-1F44-6D08F193D3EC}"/>
+              </a:ext>
+            </a:extLst>
+          </p:cNvPr>
+          <p:cNvCxnSpPr>
+            <a:cxnSpLocks/>
+            <a:stCxn id="4" idx="3"/>
+            <a:endCxn id="20" idx="1"/>
+          </p:cNvCxnSpPr>
+          <p:nvPr/>
+        </p:nvCxnSpPr>
+        <p:spPr>
+          <a:xfrm flipV="1">
+            <a:off x="7057450" y="3202446"/>
+            <a:ext cx="1536274" cy="151377"/>
+          </a:xfrm>
+          <a:prstGeom prst="straightConnector1">
+            <a:avLst/>
+          </a:prstGeom>
+          <a:ln>
+            <a:tailEnd type="triangle"/>
+          </a:ln>
+        </p:spPr>
+        <p:style>
+          <a:lnRef idx="2">
+            <a:schemeClr val="accent1"/>
+          </a:lnRef>
+          <a:fillRef idx="0">
+            <a:schemeClr val="accent1"/>
+          </a:fillRef>
+          <a:effectRef idx="1">
+            <a:schemeClr val="accent1"/>
+          </a:effectRef>
+          <a:fontRef idx="minor">
+            <a:schemeClr val="tx1"/>
+          </a:fontRef>
+        </p:style>
+      </p:cxnSp>
+      <p:sp>
+        <p:nvSpPr>
+          <p:cNvPr id="20" name="Rectangle 19">
+            <a:extLst>
+              <a:ext uri="{FF2B5EF4-FFF2-40B4-BE49-F238E27FC236}">
+                <a16:creationId xmlns:a16="http://schemas.microsoft.com/office/drawing/2014/main" id="{EF8AEEC3-690D-C735-18B9-697B0F344FCA}"/>
+              </a:ext>
+            </a:extLst>
+          </p:cNvPr>
+          <p:cNvSpPr/>
+          <p:nvPr/>
+        </p:nvSpPr>
+        <p:spPr>
+          <a:xfrm>
+            <a:off x="8593724" y="2843436"/>
+            <a:ext cx="1681514" cy="718019"/>
+          </a:xfrm>
+          <a:prstGeom prst="rect">
+            <a:avLst/>
+          </a:prstGeom>
+        </p:spPr>
+        <p:style>
+          <a:lnRef idx="2">
+            <a:schemeClr val="accent3">
+              <a:shade val="15000"/>
+            </a:schemeClr>
+          </a:lnRef>
+          <a:fillRef idx="1">
+            <a:schemeClr val="accent3"/>
+          </a:fillRef>
+          <a:effectRef idx="0">
+            <a:schemeClr val="accent3"/>
+          </a:effectRef>
+          <a:fontRef idx="minor">
+            <a:schemeClr val="lt1"/>
+          </a:fontRef>
+        </p:style>
+        <p:txBody>
+          <a:bodyPr rtlCol="0" anchor="ctr"/>
+          <a:lstStyle/>
+          <a:p>
+            <a:pPr algn="ctr"/>
+            <a:r>
+              <a:rPr lang="pl-PL" dirty="0" err="1"/>
+              <a:t>dim_client</a:t>
+            </a:r>
+            <a:endParaRPr lang="pl-PL" dirty="0"/>
+          </a:p>
+        </p:txBody>
+      </p:sp>
+      <p:sp>
+        <p:nvSpPr>
+          <p:cNvPr id="23" name="Rectangle 22">
+            <a:extLst>
+              <a:ext uri="{FF2B5EF4-FFF2-40B4-BE49-F238E27FC236}">
+                <a16:creationId xmlns:a16="http://schemas.microsoft.com/office/drawing/2014/main" id="{C93ABA3F-9C42-26B8-6929-3D076F046E4A}"/>
+              </a:ext>
+            </a:extLst>
+          </p:cNvPr>
+          <p:cNvSpPr/>
+          <p:nvPr/>
+        </p:nvSpPr>
+        <p:spPr>
+          <a:xfrm>
+            <a:off x="5768698" y="1571050"/>
+            <a:ext cx="1007479" cy="641276"/>
+          </a:xfrm>
+          <a:prstGeom prst="rect">
+            <a:avLst/>
+          </a:prstGeom>
+        </p:spPr>
+        <p:style>
+          <a:lnRef idx="2">
+            <a:schemeClr val="accent2">
+              <a:shade val="15000"/>
+            </a:schemeClr>
+          </a:lnRef>
+          <a:fillRef idx="1">
+            <a:schemeClr val="accent2"/>
+          </a:fillRef>
+          <a:effectRef idx="0">
+            <a:schemeClr val="accent2"/>
+          </a:effectRef>
+          <a:fontRef idx="minor">
+            <a:schemeClr val="lt1"/>
+          </a:fontRef>
+        </p:style>
+        <p:txBody>
+          <a:bodyPr rtlCol="0" anchor="ctr"/>
+          <a:lstStyle/>
+          <a:p>
+            <a:pPr algn="ctr"/>
+            <a:r>
+              <a:rPr lang="pl-PL" dirty="0" err="1"/>
+              <a:t>loans</a:t>
+            </a:r>
+            <a:endParaRPr lang="pl-PL" dirty="0"/>
+          </a:p>
+        </p:txBody>
+      </p:sp>
+      <p:sp>
+        <p:nvSpPr>
+          <p:cNvPr id="24" name="Rectangle 23">
+            <a:extLst>
+              <a:ext uri="{FF2B5EF4-FFF2-40B4-BE49-F238E27FC236}">
+                <a16:creationId xmlns:a16="http://schemas.microsoft.com/office/drawing/2014/main" id="{0D839981-3355-D878-B91D-14ECB39FACF3}"/>
+              </a:ext>
+            </a:extLst>
+          </p:cNvPr>
+          <p:cNvSpPr/>
+          <p:nvPr/>
+        </p:nvSpPr>
+        <p:spPr>
+          <a:xfrm>
+            <a:off x="3443190" y="2125929"/>
+            <a:ext cx="1223550" cy="641276"/>
+          </a:xfrm>
+          <a:prstGeom prst="rect">
+            <a:avLst/>
+          </a:prstGeom>
+        </p:spPr>
+        <p:style>
+          <a:lnRef idx="2">
+            <a:schemeClr val="accent2">
+              <a:shade val="15000"/>
+            </a:schemeClr>
+          </a:lnRef>
+          <a:fillRef idx="1">
+            <a:schemeClr val="accent2"/>
+          </a:fillRef>
+          <a:effectRef idx="0">
+            <a:schemeClr val="accent2"/>
+          </a:effectRef>
+          <a:fontRef idx="minor">
+            <a:schemeClr val="lt1"/>
+          </a:fontRef>
+        </p:style>
+        <p:txBody>
+          <a:bodyPr rtlCol="0" anchor="ctr"/>
+          <a:lstStyle/>
+          <a:p>
+            <a:pPr algn="ctr"/>
+            <a:r>
+              <a:rPr lang="pl-PL" dirty="0" err="1"/>
+              <a:t>deposits</a:t>
+            </a:r>
+            <a:endParaRPr lang="pl-PL" dirty="0"/>
+          </a:p>
+        </p:txBody>
+      </p:sp>
+      <p:sp>
+        <p:nvSpPr>
+          <p:cNvPr id="31" name="TextBox 30">
+            <a:extLst>
+              <a:ext uri="{FF2B5EF4-FFF2-40B4-BE49-F238E27FC236}">
+                <a16:creationId xmlns:a16="http://schemas.microsoft.com/office/drawing/2014/main" id="{AB25C882-881D-8396-B560-5D6CC28C4D96}"/>
+              </a:ext>
+            </a:extLst>
+          </p:cNvPr>
+          <p:cNvSpPr txBox="1"/>
+          <p:nvPr/>
+        </p:nvSpPr>
+        <p:spPr>
+          <a:xfrm>
+            <a:off x="8593724" y="3761928"/>
+            <a:ext cx="1839028" cy="1754326"/>
+          </a:xfrm>
+          <a:prstGeom prst="rect">
+            <a:avLst/>
+          </a:prstGeom>
+          <a:noFill/>
+        </p:spPr>
+        <p:txBody>
+          <a:bodyPr wrap="square" rtlCol="0">
+            <a:spAutoFit/>
+          </a:bodyPr>
+          <a:lstStyle/>
+          <a:p>
+            <a:r>
+              <a:rPr lang="pl-PL" dirty="0" err="1"/>
+              <a:t>Client_id</a:t>
+            </a:r>
+            <a:endParaRPr lang="pl-PL" dirty="0"/>
+          </a:p>
+          <a:p>
+            <a:r>
+              <a:rPr lang="pl-PL" dirty="0"/>
+              <a:t>Client </a:t>
+            </a:r>
+            <a:r>
+              <a:rPr lang="pl-PL" dirty="0" err="1"/>
+              <a:t>name</a:t>
+            </a:r>
+            <a:endParaRPr lang="pl-PL" dirty="0"/>
+          </a:p>
+          <a:p>
+            <a:r>
+              <a:rPr lang="pl-PL" dirty="0"/>
+              <a:t>Client </a:t>
+            </a:r>
+            <a:r>
+              <a:rPr lang="pl-PL" dirty="0" err="1"/>
+              <a:t>surname</a:t>
+            </a:r>
+            <a:endParaRPr lang="pl-PL" dirty="0"/>
+          </a:p>
+          <a:p>
+            <a:r>
+              <a:rPr lang="pl-PL" dirty="0" err="1"/>
+              <a:t>Client_type</a:t>
+            </a:r>
+            <a:endParaRPr lang="pl-PL" dirty="0"/>
+          </a:p>
+          <a:p>
+            <a:r>
+              <a:rPr lang="pl-PL" dirty="0" err="1"/>
+              <a:t>Client_region</a:t>
+            </a:r>
+            <a:endParaRPr lang="pl-PL" dirty="0"/>
+          </a:p>
+          <a:p>
+            <a:r>
+              <a:rPr lang="pl-PL" dirty="0" err="1"/>
+              <a:t>Client_rating</a:t>
+            </a:r>
+            <a:endParaRPr lang="pl-PL" dirty="0"/>
+          </a:p>
+        </p:txBody>
+      </p:sp>
+      <p:sp>
+        <p:nvSpPr>
+          <p:cNvPr id="32" name="TextBox 31">
+            <a:extLst>
+              <a:ext uri="{FF2B5EF4-FFF2-40B4-BE49-F238E27FC236}">
+                <a16:creationId xmlns:a16="http://schemas.microsoft.com/office/drawing/2014/main" id="{9B4BE956-B29B-0FF9-32BE-17AAE76095A0}"/>
+              </a:ext>
+            </a:extLst>
+          </p:cNvPr>
+          <p:cNvSpPr txBox="1"/>
+          <p:nvPr/>
+        </p:nvSpPr>
+        <p:spPr>
+          <a:xfrm>
+            <a:off x="1872650" y="2024417"/>
+            <a:ext cx="1527069" cy="923330"/>
+          </a:xfrm>
+          <a:prstGeom prst="rect">
+            <a:avLst/>
+          </a:prstGeom>
+          <a:noFill/>
+        </p:spPr>
+        <p:txBody>
+          <a:bodyPr wrap="square" rtlCol="0">
+            <a:spAutoFit/>
+          </a:bodyPr>
+          <a:lstStyle/>
+          <a:p>
+            <a:r>
+              <a:rPr lang="pl-PL" dirty="0"/>
+              <a:t>SA, CA, </a:t>
+            </a:r>
+            <a:r>
+              <a:rPr lang="pl-PL" dirty="0" err="1"/>
+              <a:t>term_depo</a:t>
+            </a:r>
+            <a:r>
+              <a:rPr lang="pl-PL" dirty="0"/>
+              <a:t>, bank depo</a:t>
+            </a:r>
+          </a:p>
+        </p:txBody>
+      </p:sp>
+      <p:sp>
+        <p:nvSpPr>
+          <p:cNvPr id="33" name="TextBox 32">
+            <a:extLst>
+              <a:ext uri="{FF2B5EF4-FFF2-40B4-BE49-F238E27FC236}">
+                <a16:creationId xmlns:a16="http://schemas.microsoft.com/office/drawing/2014/main" id="{0503C1CE-AA6C-B526-0E28-61C82C9036B8}"/>
+              </a:ext>
+            </a:extLst>
+          </p:cNvPr>
+          <p:cNvSpPr txBox="1"/>
+          <p:nvPr/>
+        </p:nvSpPr>
+        <p:spPr>
+          <a:xfrm>
+            <a:off x="6806862" y="1320235"/>
+            <a:ext cx="2044618" cy="1200329"/>
+          </a:xfrm>
+          <a:prstGeom prst="rect">
+            <a:avLst/>
+          </a:prstGeom>
+          <a:noFill/>
+        </p:spPr>
+        <p:txBody>
+          <a:bodyPr wrap="square" rtlCol="0">
+            <a:spAutoFit/>
+          </a:bodyPr>
+          <a:lstStyle/>
+          <a:p>
+            <a:r>
+              <a:rPr lang="pl-PL" dirty="0" err="1"/>
+              <a:t>Mortgages</a:t>
+            </a:r>
+            <a:r>
+              <a:rPr lang="pl-PL" dirty="0"/>
+              <a:t>, </a:t>
+            </a:r>
+            <a:r>
+              <a:rPr lang="pl-PL" dirty="0" err="1"/>
+              <a:t>cash</a:t>
+            </a:r>
+            <a:r>
+              <a:rPr lang="pl-PL" dirty="0"/>
+              <a:t> </a:t>
+            </a:r>
+            <a:r>
+              <a:rPr lang="pl-PL" dirty="0" err="1"/>
+              <a:t>loans</a:t>
+            </a:r>
+            <a:r>
+              <a:rPr lang="pl-PL" dirty="0"/>
+              <a:t>, </a:t>
+            </a:r>
+            <a:r>
+              <a:rPr lang="pl-PL" dirty="0" err="1"/>
+              <a:t>subordinated</a:t>
+            </a:r>
+            <a:r>
+              <a:rPr lang="pl-PL" dirty="0"/>
+              <a:t> </a:t>
+            </a:r>
+            <a:r>
+              <a:rPr lang="pl-PL" dirty="0" err="1"/>
+              <a:t>loans</a:t>
+            </a:r>
+            <a:r>
+              <a:rPr lang="pl-PL" dirty="0"/>
+              <a:t>(</a:t>
+            </a:r>
+            <a:r>
+              <a:rPr lang="pl-PL" dirty="0" err="1"/>
+              <a:t>liability</a:t>
+            </a:r>
+            <a:r>
+              <a:rPr lang="pl-PL" dirty="0"/>
+              <a:t>)</a:t>
+            </a:r>
+          </a:p>
+        </p:txBody>
+      </p:sp>
+      <p:sp>
+        <p:nvSpPr>
+          <p:cNvPr id="34" name="Rectangle 33">
+            <a:extLst>
+              <a:ext uri="{FF2B5EF4-FFF2-40B4-BE49-F238E27FC236}">
+                <a16:creationId xmlns:a16="http://schemas.microsoft.com/office/drawing/2014/main" id="{1AE008E3-546B-6FF5-337C-CEBE4FF9BA36}"/>
+              </a:ext>
+            </a:extLst>
+          </p:cNvPr>
+          <p:cNvSpPr/>
+          <p:nvPr/>
+        </p:nvSpPr>
+        <p:spPr>
+          <a:xfrm>
+            <a:off x="2872075" y="3824319"/>
+            <a:ext cx="1891130" cy="859168"/>
+          </a:xfrm>
+          <a:prstGeom prst="rect">
+            <a:avLst/>
+          </a:prstGeom>
+        </p:spPr>
+        <p:style>
+          <a:lnRef idx="2">
+            <a:schemeClr val="accent2">
+              <a:shade val="15000"/>
+            </a:schemeClr>
+          </a:lnRef>
+          <a:fillRef idx="1">
+            <a:schemeClr val="accent2"/>
+          </a:fillRef>
+          <a:effectRef idx="0">
+            <a:schemeClr val="accent2"/>
+          </a:effectRef>
+          <a:fontRef idx="minor">
+            <a:schemeClr val="lt1"/>
+          </a:fontRef>
+        </p:style>
+        <p:txBody>
+          <a:bodyPr rtlCol="0" anchor="ctr"/>
+          <a:lstStyle/>
+          <a:p>
+            <a:pPr algn="ctr"/>
+            <a:r>
+              <a:rPr lang="pl-PL" dirty="0" err="1"/>
+              <a:t>off_balance_commitment</a:t>
+            </a:r>
+            <a:endParaRPr lang="pl-PL" dirty="0"/>
+          </a:p>
+        </p:txBody>
+      </p:sp>
+      <p:sp>
+        <p:nvSpPr>
+          <p:cNvPr id="36" name="TextBox 35">
+            <a:extLst>
+              <a:ext uri="{FF2B5EF4-FFF2-40B4-BE49-F238E27FC236}">
+                <a16:creationId xmlns:a16="http://schemas.microsoft.com/office/drawing/2014/main" id="{6C2297E2-C350-11A7-AB11-2E900C37F15B}"/>
+              </a:ext>
+            </a:extLst>
+          </p:cNvPr>
+          <p:cNvSpPr txBox="1"/>
+          <p:nvPr/>
+        </p:nvSpPr>
+        <p:spPr>
+          <a:xfrm>
+            <a:off x="820139" y="3761928"/>
+            <a:ext cx="1839028" cy="923330"/>
+          </a:xfrm>
+          <a:prstGeom prst="rect">
+            <a:avLst/>
+          </a:prstGeom>
+          <a:noFill/>
+        </p:spPr>
+        <p:txBody>
+          <a:bodyPr wrap="square" rtlCol="0">
+            <a:spAutoFit/>
+          </a:bodyPr>
+          <a:lstStyle/>
+          <a:p>
+            <a:r>
+              <a:rPr lang="pl-PL" dirty="0" err="1"/>
+              <a:t>Letter_off_credit</a:t>
+            </a:r>
+            <a:r>
+              <a:rPr lang="pl-PL" dirty="0"/>
+              <a:t>, </a:t>
+            </a:r>
+            <a:r>
+              <a:rPr lang="pl-PL" dirty="0" err="1"/>
+              <a:t>guarentes</a:t>
+            </a:r>
+            <a:r>
+              <a:rPr lang="pl-PL" dirty="0"/>
+              <a:t>, </a:t>
+            </a:r>
+            <a:r>
+              <a:rPr lang="pl-PL" dirty="0" err="1"/>
+              <a:t>credit</a:t>
+            </a:r>
+            <a:r>
+              <a:rPr lang="pl-PL" dirty="0"/>
+              <a:t> lines,</a:t>
+            </a:r>
+          </a:p>
+        </p:txBody>
+      </p:sp>
+      <p:sp>
+        <p:nvSpPr>
+          <p:cNvPr id="39" name="Rectangle 38">
+            <a:extLst>
+              <a:ext uri="{FF2B5EF4-FFF2-40B4-BE49-F238E27FC236}">
+                <a16:creationId xmlns:a16="http://schemas.microsoft.com/office/drawing/2014/main" id="{5604A122-7573-E1DE-B956-EB0D51718582}"/>
+              </a:ext>
+            </a:extLst>
+          </p:cNvPr>
+          <p:cNvSpPr/>
+          <p:nvPr/>
+        </p:nvSpPr>
+        <p:spPr>
+          <a:xfrm>
+            <a:off x="6621250" y="5016958"/>
+            <a:ext cx="1891130" cy="859168"/>
+          </a:xfrm>
+          <a:prstGeom prst="rect">
+            <a:avLst/>
+          </a:prstGeom>
+        </p:spPr>
+        <p:style>
+          <a:lnRef idx="2">
+            <a:schemeClr val="accent2">
+              <a:shade val="15000"/>
+            </a:schemeClr>
+          </a:lnRef>
+          <a:fillRef idx="1">
+            <a:schemeClr val="accent2"/>
+          </a:fillRef>
+          <a:effectRef idx="0">
+            <a:schemeClr val="accent2"/>
+          </a:effectRef>
+          <a:fontRef idx="minor">
+            <a:schemeClr val="lt1"/>
+          </a:fontRef>
+        </p:style>
+        <p:txBody>
+          <a:bodyPr rtlCol="0" anchor="ctr"/>
+          <a:lstStyle/>
+          <a:p>
+            <a:pPr algn="ctr"/>
+            <a:r>
+              <a:rPr lang="pl-PL" dirty="0" err="1"/>
+              <a:t>Financal_instruments</a:t>
+            </a:r>
+            <a:endParaRPr lang="pl-PL" dirty="0"/>
+          </a:p>
+        </p:txBody>
+      </p:sp>
+      <p:sp>
+        <p:nvSpPr>
+          <p:cNvPr id="41" name="TextBox 40">
+            <a:extLst>
+              <a:ext uri="{FF2B5EF4-FFF2-40B4-BE49-F238E27FC236}">
+                <a16:creationId xmlns:a16="http://schemas.microsoft.com/office/drawing/2014/main" id="{77FADC09-2354-C6E6-81D6-DB822B2F0F09}"/>
+              </a:ext>
+            </a:extLst>
+          </p:cNvPr>
+          <p:cNvSpPr txBox="1"/>
+          <p:nvPr/>
+        </p:nvSpPr>
+        <p:spPr>
+          <a:xfrm>
+            <a:off x="3817640" y="6028526"/>
+            <a:ext cx="1839028" cy="369332"/>
+          </a:xfrm>
+          <a:prstGeom prst="rect">
+            <a:avLst/>
+          </a:prstGeom>
+          <a:noFill/>
+        </p:spPr>
+        <p:txBody>
+          <a:bodyPr wrap="square" rtlCol="0">
+            <a:spAutoFit/>
+          </a:bodyPr>
+          <a:lstStyle/>
+          <a:p>
+            <a:r>
+              <a:rPr lang="pl-PL" dirty="0"/>
+              <a:t>IRS, CIRS </a:t>
+            </a:r>
+          </a:p>
+        </p:txBody>
+      </p:sp>
+      <p:sp>
+        <p:nvSpPr>
+          <p:cNvPr id="42" name="Rectangle 41">
+            <a:extLst>
+              <a:ext uri="{FF2B5EF4-FFF2-40B4-BE49-F238E27FC236}">
+                <a16:creationId xmlns:a16="http://schemas.microsoft.com/office/drawing/2014/main" id="{ADCAF0ED-B858-736A-B612-997AF4AC0CEA}"/>
+              </a:ext>
+            </a:extLst>
+          </p:cNvPr>
+          <p:cNvSpPr/>
+          <p:nvPr/>
+        </p:nvSpPr>
+        <p:spPr>
+          <a:xfrm>
+            <a:off x="3679621" y="5086670"/>
+            <a:ext cx="1891130" cy="859168"/>
+          </a:xfrm>
+          <a:prstGeom prst="rect">
+            <a:avLst/>
+          </a:prstGeom>
+        </p:spPr>
+        <p:style>
+          <a:lnRef idx="2">
+            <a:schemeClr val="accent2">
+              <a:shade val="15000"/>
+            </a:schemeClr>
+          </a:lnRef>
+          <a:fillRef idx="1">
+            <a:schemeClr val="accent2"/>
+          </a:fillRef>
+          <a:effectRef idx="0">
+            <a:schemeClr val="accent2"/>
+          </a:effectRef>
+          <a:fontRef idx="minor">
+            <a:schemeClr val="lt1"/>
+          </a:fontRef>
+        </p:style>
+        <p:txBody>
+          <a:bodyPr rtlCol="0" anchor="ctr"/>
+          <a:lstStyle/>
+          <a:p>
+            <a:pPr algn="ctr"/>
+            <a:r>
+              <a:rPr lang="pl-PL" dirty="0" err="1"/>
+              <a:t>derivatives</a:t>
+            </a:r>
+            <a:endParaRPr lang="pl-PL" dirty="0"/>
+          </a:p>
+        </p:txBody>
+      </p:sp>
+      <p:cxnSp>
+        <p:nvCxnSpPr>
+          <p:cNvPr id="43" name="Straight Arrow Connector 42">
+            <a:extLst>
+              <a:ext uri="{FF2B5EF4-FFF2-40B4-BE49-F238E27FC236}">
+                <a16:creationId xmlns:a16="http://schemas.microsoft.com/office/drawing/2014/main" id="{F4E7ADC4-A071-82D7-C279-7F3AEADF2835}"/>
+              </a:ext>
+            </a:extLst>
+          </p:cNvPr>
+          <p:cNvCxnSpPr>
+            <a:cxnSpLocks/>
+            <a:endCxn id="42" idx="0"/>
+          </p:cNvCxnSpPr>
+          <p:nvPr/>
+        </p:nvCxnSpPr>
+        <p:spPr>
+          <a:xfrm flipH="1">
+            <a:off x="4625186" y="3633995"/>
+            <a:ext cx="1285141" cy="1452675"/>
+          </a:xfrm>
+          <a:prstGeom prst="straightConnector1">
+            <a:avLst/>
+          </a:prstGeom>
+          <a:ln>
+            <a:tailEnd type="triangle"/>
+          </a:ln>
+        </p:spPr>
+        <p:style>
+          <a:lnRef idx="2">
+            <a:schemeClr val="accent1"/>
+          </a:lnRef>
+          <a:fillRef idx="0">
+            <a:schemeClr val="accent1"/>
+          </a:fillRef>
+          <a:effectRef idx="1">
+            <a:schemeClr val="accent1"/>
+          </a:effectRef>
+          <a:fontRef idx="minor">
+            <a:schemeClr val="tx1"/>
+          </a:fontRef>
+        </p:style>
+      </p:cxnSp>
+      <p:sp>
+        <p:nvSpPr>
+          <p:cNvPr id="45" name="TextBox 44">
+            <a:extLst>
+              <a:ext uri="{FF2B5EF4-FFF2-40B4-BE49-F238E27FC236}">
+                <a16:creationId xmlns:a16="http://schemas.microsoft.com/office/drawing/2014/main" id="{11A6C47C-6051-62BB-E6DA-81399902518B}"/>
+              </a:ext>
+            </a:extLst>
+          </p:cNvPr>
+          <p:cNvSpPr txBox="1"/>
+          <p:nvPr/>
+        </p:nvSpPr>
+        <p:spPr>
+          <a:xfrm>
+            <a:off x="7058473" y="6028526"/>
+            <a:ext cx="1839028" cy="369332"/>
+          </a:xfrm>
+          <a:prstGeom prst="rect">
+            <a:avLst/>
+          </a:prstGeom>
+          <a:noFill/>
+        </p:spPr>
+        <p:txBody>
+          <a:bodyPr wrap="square" rtlCol="0">
+            <a:spAutoFit/>
+          </a:bodyPr>
+          <a:lstStyle/>
+          <a:p>
+            <a:r>
+              <a:rPr lang="pl-PL" dirty="0" err="1"/>
+              <a:t>Bonds</a:t>
+            </a:r>
+            <a:r>
+              <a:rPr lang="pl-PL" dirty="0"/>
+              <a:t>, </a:t>
+            </a:r>
+            <a:r>
+              <a:rPr lang="pl-PL" dirty="0" err="1"/>
+              <a:t>stocks</a:t>
+            </a:r>
+            <a:endParaRPr lang="pl-PL" dirty="0"/>
+          </a:p>
+        </p:txBody>
+      </p:sp>
+      <p:sp>
+        <p:nvSpPr>
+          <p:cNvPr id="46" name="Rectangle 45">
+            <a:extLst>
+              <a:ext uri="{FF2B5EF4-FFF2-40B4-BE49-F238E27FC236}">
+                <a16:creationId xmlns:a16="http://schemas.microsoft.com/office/drawing/2014/main" id="{9E8C7245-9B37-3721-ED9E-1B6CCE7D62ED}"/>
+              </a:ext>
+            </a:extLst>
+          </p:cNvPr>
+          <p:cNvSpPr/>
+          <p:nvPr/>
+        </p:nvSpPr>
+        <p:spPr>
+          <a:xfrm>
+            <a:off x="9137866" y="418317"/>
+            <a:ext cx="1891130" cy="859168"/>
+          </a:xfrm>
+          <a:prstGeom prst="rect">
+            <a:avLst/>
+          </a:prstGeom>
+        </p:spPr>
+        <p:style>
+          <a:lnRef idx="2">
+            <a:schemeClr val="accent2">
+              <a:shade val="15000"/>
+            </a:schemeClr>
+          </a:lnRef>
+          <a:fillRef idx="1">
+            <a:schemeClr val="accent2"/>
+          </a:fillRef>
+          <a:effectRef idx="0">
+            <a:schemeClr val="accent2"/>
+          </a:effectRef>
+          <a:fontRef idx="minor">
+            <a:schemeClr val="lt1"/>
+          </a:fontRef>
+        </p:style>
+        <p:txBody>
+          <a:bodyPr rtlCol="0" anchor="ctr"/>
+          <a:lstStyle/>
+          <a:p>
+            <a:pPr algn="ctr"/>
+            <a:r>
+              <a:rPr lang="pl-PL" dirty="0"/>
+              <a:t>equity</a:t>
+            </a:r>
+          </a:p>
+        </p:txBody>
+      </p:sp>
+      <p:cxnSp>
+        <p:nvCxnSpPr>
+          <p:cNvPr id="47" name="Straight Arrow Connector 46">
+            <a:extLst>
+              <a:ext uri="{FF2B5EF4-FFF2-40B4-BE49-F238E27FC236}">
+                <a16:creationId xmlns:a16="http://schemas.microsoft.com/office/drawing/2014/main" id="{8EF41895-40AB-26B3-55C6-B17B336A665A}"/>
+              </a:ext>
+            </a:extLst>
+          </p:cNvPr>
+          <p:cNvCxnSpPr>
+            <a:cxnSpLocks/>
+            <a:endCxn id="46" idx="2"/>
+          </p:cNvCxnSpPr>
+          <p:nvPr/>
+        </p:nvCxnSpPr>
+        <p:spPr>
+          <a:xfrm flipV="1">
+            <a:off x="7057450" y="1277485"/>
+            <a:ext cx="3025981" cy="1843023"/>
+          </a:xfrm>
+          <a:prstGeom prst="straightConnector1">
+            <a:avLst/>
+          </a:prstGeom>
+          <a:ln>
+            <a:tailEnd type="triangle"/>
+          </a:ln>
+        </p:spPr>
+        <p:style>
+          <a:lnRef idx="2">
+            <a:schemeClr val="accent1"/>
+          </a:lnRef>
+          <a:fillRef idx="0">
+            <a:schemeClr val="accent1"/>
+          </a:fillRef>
+          <a:effectRef idx="1">
+            <a:schemeClr val="accent1"/>
+          </a:effectRef>
+          <a:fontRef idx="minor">
+            <a:schemeClr val="tx1"/>
+          </a:fontRef>
+        </p:style>
+      </p:cxnSp>
+    </p:spTree>
+    <p:extLst>
+      <p:ext uri="{BB962C8B-B14F-4D97-AF65-F5344CB8AC3E}">
+        <p14:creationId xmlns:p14="http://schemas.microsoft.com/office/powerpoint/2010/main" val="1455576378"/>
+      </p:ext>
+    </p:extLst>
+  </p:cSld>
+  <p:clrMapOvr>
+    <a:masterClrMapping/>
+  </p:clrMapOvr>
+</p:sld>
+</file>
+
+<file path=ppt/slides/slide4.xml><?xml version="1.0" encoding="utf-8"?>
+<p:sld xmlns:a="http://schemas.openxmlformats.org/drawingml/2006/main" xmlns:r="http://schemas.openxmlformats.org/officeDocument/2006/relationships" xmlns:p="http://schemas.openxmlformats.org/presentationml/2006/main">
+  <p:cSld>
+    <p:spTree>
+      <p:nvGrpSpPr>
+        <p:cNvPr id="1" name="">
+          <a:extLst>
+            <a:ext uri="{FF2B5EF4-FFF2-40B4-BE49-F238E27FC236}">
+              <a16:creationId xmlns:a16="http://schemas.microsoft.com/office/drawing/2014/main" id="{8E033DAA-3B1E-4962-7236-BC221AD14111}"/>
+            </a:ext>
+          </a:extLst>
+        </p:cNvPr>
+        <p:cNvGrpSpPr/>
+        <p:nvPr/>
+      </p:nvGrpSpPr>
+      <p:grpSpPr>
+        <a:xfrm>
+          <a:off x="0" y="0"/>
+          <a:ext cx="0" cy="0"/>
+          <a:chOff x="0" y="0"/>
+          <a:chExt cx="0" cy="0"/>
+        </a:xfrm>
+      </p:grpSpPr>
+      <p:sp>
+        <p:nvSpPr>
+          <p:cNvPr id="2" name="Title 1">
+            <a:extLst>
+              <a:ext uri="{FF2B5EF4-FFF2-40B4-BE49-F238E27FC236}">
+                <a16:creationId xmlns:a16="http://schemas.microsoft.com/office/drawing/2014/main" id="{9E149151-49CD-4CE0-3DBC-E4ECAAAD7E41}"/>
+              </a:ext>
+            </a:extLst>
+          </p:cNvPr>
+          <p:cNvSpPr>
+            <a:spLocks noGrp="1"/>
+          </p:cNvSpPr>
+          <p:nvPr>
+            <p:ph type="title"/>
+          </p:nvPr>
+        </p:nvSpPr>
+        <p:spPr/>
+        <p:txBody>
+          <a:bodyPr/>
+          <a:lstStyle/>
+          <a:p>
+            <a:r>
+              <a:rPr lang="pl-PL" dirty="0" err="1"/>
+              <a:t>Phase</a:t>
+            </a:r>
+            <a:r>
+              <a:rPr lang="pl-PL" dirty="0"/>
+              <a:t> 0 -  SQL </a:t>
+            </a:r>
+            <a:r>
+              <a:rPr lang="pl-PL" dirty="0" err="1"/>
+              <a:t>schema</a:t>
+            </a:r>
+            <a:r>
+              <a:rPr lang="pl-PL" dirty="0"/>
+              <a:t> </a:t>
+            </a:r>
+            <a:r>
+              <a:rPr lang="pl-PL" dirty="0" err="1"/>
+              <a:t>base</a:t>
+            </a:r>
+            <a:r>
+              <a:rPr lang="pl-PL" dirty="0"/>
+              <a:t> </a:t>
+            </a:r>
+            <a:r>
+              <a:rPr lang="pl-PL" dirty="0" err="1"/>
+              <a:t>example</a:t>
+            </a:r>
+            <a:r>
+              <a:rPr lang="pl-PL" dirty="0"/>
+              <a:t> (</a:t>
+            </a:r>
+            <a:r>
+              <a:rPr lang="pl-PL" dirty="0" err="1"/>
+              <a:t>only</a:t>
+            </a:r>
+            <a:r>
+              <a:rPr lang="pl-PL" dirty="0"/>
+              <a:t> PLN, IRS, no </a:t>
+            </a:r>
+            <a:r>
+              <a:rPr lang="pl-PL" dirty="0" err="1"/>
+              <a:t>off_balance</a:t>
+            </a:r>
+            <a:r>
+              <a:rPr lang="pl-PL" dirty="0"/>
+              <a:t>) </a:t>
+            </a:r>
+          </a:p>
+        </p:txBody>
+      </p:sp>
+      <p:sp>
+        <p:nvSpPr>
+          <p:cNvPr id="4" name="Rectangle 3">
+            <a:extLst>
+              <a:ext uri="{FF2B5EF4-FFF2-40B4-BE49-F238E27FC236}">
+                <a16:creationId xmlns:a16="http://schemas.microsoft.com/office/drawing/2014/main" id="{E76380C3-A814-0E64-5D0A-18E5D376E1A5}"/>
+              </a:ext>
+            </a:extLst>
+          </p:cNvPr>
+          <p:cNvSpPr/>
+          <p:nvPr/>
+        </p:nvSpPr>
+        <p:spPr>
+          <a:xfrm>
+            <a:off x="5406620" y="3093004"/>
+            <a:ext cx="1650830" cy="521638"/>
+          </a:xfrm>
+          <a:prstGeom prst="rect">
+            <a:avLst/>
+          </a:prstGeom>
+        </p:spPr>
+        <p:style>
+          <a:lnRef idx="2">
+            <a:schemeClr val="accent1">
+              <a:shade val="15000"/>
+            </a:schemeClr>
+          </a:lnRef>
+          <a:fillRef idx="1">
+            <a:schemeClr val="accent1"/>
+          </a:fillRef>
+          <a:effectRef idx="0">
+            <a:schemeClr val="accent1"/>
+          </a:effectRef>
+          <a:fontRef idx="minor">
+            <a:schemeClr val="lt1"/>
+          </a:fontRef>
+        </p:style>
+        <p:txBody>
+          <a:bodyPr rtlCol="0" anchor="ctr"/>
+          <a:lstStyle/>
+          <a:p>
+            <a:pPr algn="ctr"/>
+            <a:r>
+              <a:rPr lang="pl-PL" dirty="0" err="1"/>
+              <a:t>transactions</a:t>
+            </a:r>
+            <a:endParaRPr lang="pl-PL" dirty="0"/>
+          </a:p>
+        </p:txBody>
+      </p:sp>
+      <p:cxnSp>
+        <p:nvCxnSpPr>
+          <p:cNvPr id="6" name="Straight Arrow Connector 5">
+            <a:extLst>
+              <a:ext uri="{FF2B5EF4-FFF2-40B4-BE49-F238E27FC236}">
+                <a16:creationId xmlns:a16="http://schemas.microsoft.com/office/drawing/2014/main" id="{370C88DD-7C67-1F35-CE7F-ED69105D8388}"/>
+              </a:ext>
+            </a:extLst>
+          </p:cNvPr>
+          <p:cNvCxnSpPr>
+            <a:stCxn id="4" idx="0"/>
+          </p:cNvCxnSpPr>
+          <p:nvPr/>
+        </p:nvCxnSpPr>
+        <p:spPr>
+          <a:xfrm flipH="1" flipV="1">
+            <a:off x="6222830" y="2233836"/>
+            <a:ext cx="9205" cy="859168"/>
+          </a:xfrm>
+          <a:prstGeom prst="straightConnector1">
+            <a:avLst/>
+          </a:prstGeom>
+          <a:ln>
+            <a:tailEnd type="triangle"/>
+          </a:ln>
+        </p:spPr>
+        <p:style>
+          <a:lnRef idx="2">
+            <a:schemeClr val="accent1"/>
+          </a:lnRef>
+          <a:fillRef idx="0">
+            <a:schemeClr val="accent1"/>
+          </a:fillRef>
+          <a:effectRef idx="1">
+            <a:schemeClr val="accent1"/>
+          </a:effectRef>
+          <a:fontRef idx="minor">
+            <a:schemeClr val="tx1"/>
+          </a:fontRef>
+        </p:style>
+      </p:cxnSp>
+      <p:cxnSp>
+        <p:nvCxnSpPr>
+          <p:cNvPr id="7" name="Straight Arrow Connector 6">
+            <a:extLst>
+              <a:ext uri="{FF2B5EF4-FFF2-40B4-BE49-F238E27FC236}">
+                <a16:creationId xmlns:a16="http://schemas.microsoft.com/office/drawing/2014/main" id="{AC8229F8-31BE-8C1D-61D4-741CE1639685}"/>
+              </a:ext>
+            </a:extLst>
+          </p:cNvPr>
+          <p:cNvCxnSpPr>
+            <a:cxnSpLocks/>
+          </p:cNvCxnSpPr>
+          <p:nvPr/>
+        </p:nvCxnSpPr>
+        <p:spPr>
+          <a:xfrm flipH="1" flipV="1">
+            <a:off x="4602685" y="2843436"/>
+            <a:ext cx="813140" cy="257719"/>
+          </a:xfrm>
+          <a:prstGeom prst="straightConnector1">
+            <a:avLst/>
+          </a:prstGeom>
+          <a:ln>
+            <a:tailEnd type="triangle"/>
+          </a:ln>
+        </p:spPr>
+        <p:style>
+          <a:lnRef idx="2">
+            <a:schemeClr val="accent1"/>
+          </a:lnRef>
+          <a:fillRef idx="0">
+            <a:schemeClr val="accent1"/>
+          </a:fillRef>
+          <a:effectRef idx="1">
+            <a:schemeClr val="accent1"/>
+          </a:effectRef>
+          <a:fontRef idx="minor">
+            <a:schemeClr val="tx1"/>
+          </a:fontRef>
+        </p:style>
+      </p:cxnSp>
+      <p:cxnSp>
+        <p:nvCxnSpPr>
+          <p:cNvPr id="10" name="Straight Arrow Connector 9">
+            <a:extLst>
+              <a:ext uri="{FF2B5EF4-FFF2-40B4-BE49-F238E27FC236}">
+                <a16:creationId xmlns:a16="http://schemas.microsoft.com/office/drawing/2014/main" id="{AA83DF07-9EF5-4CD6-91B9-3CAD05050EA0}"/>
+              </a:ext>
+            </a:extLst>
+          </p:cNvPr>
+          <p:cNvCxnSpPr>
+            <a:cxnSpLocks/>
+            <a:endCxn id="39" idx="0"/>
+          </p:cNvCxnSpPr>
+          <p:nvPr/>
+        </p:nvCxnSpPr>
+        <p:spPr>
+          <a:xfrm>
+            <a:off x="6480580" y="3614642"/>
+            <a:ext cx="1086235" cy="1402316"/>
+          </a:xfrm>
+          <a:prstGeom prst="straightConnector1">
+            <a:avLst/>
+          </a:prstGeom>
+          <a:ln>
+            <a:tailEnd type="triangle"/>
+          </a:ln>
+        </p:spPr>
+        <p:style>
+          <a:lnRef idx="2">
+            <a:schemeClr val="accent1"/>
+          </a:lnRef>
+          <a:fillRef idx="0">
+            <a:schemeClr val="accent1"/>
+          </a:fillRef>
+          <a:effectRef idx="1">
+            <a:schemeClr val="accent1"/>
+          </a:effectRef>
+          <a:fontRef idx="minor">
+            <a:schemeClr val="tx1"/>
+          </a:fontRef>
+        </p:style>
+      </p:cxnSp>
+      <p:cxnSp>
+        <p:nvCxnSpPr>
+          <p:cNvPr id="11" name="Straight Arrow Connector 10">
+            <a:extLst>
+              <a:ext uri="{FF2B5EF4-FFF2-40B4-BE49-F238E27FC236}">
+                <a16:creationId xmlns:a16="http://schemas.microsoft.com/office/drawing/2014/main" id="{015DF34E-F19E-1A3E-C686-4D4BDB264858}"/>
+              </a:ext>
+            </a:extLst>
+          </p:cNvPr>
+          <p:cNvCxnSpPr>
+            <a:cxnSpLocks/>
+            <a:stCxn id="4" idx="3"/>
+            <a:endCxn id="20" idx="1"/>
+          </p:cNvCxnSpPr>
+          <p:nvPr/>
+        </p:nvCxnSpPr>
+        <p:spPr>
+          <a:xfrm flipV="1">
+            <a:off x="7057450" y="3202446"/>
+            <a:ext cx="1536274" cy="151377"/>
+          </a:xfrm>
+          <a:prstGeom prst="straightConnector1">
+            <a:avLst/>
+          </a:prstGeom>
+          <a:ln>
+            <a:tailEnd type="triangle"/>
+          </a:ln>
+        </p:spPr>
+        <p:style>
+          <a:lnRef idx="2">
+            <a:schemeClr val="accent1"/>
+          </a:lnRef>
+          <a:fillRef idx="0">
+            <a:schemeClr val="accent1"/>
+          </a:fillRef>
+          <a:effectRef idx="1">
+            <a:schemeClr val="accent1"/>
+          </a:effectRef>
+          <a:fontRef idx="minor">
+            <a:schemeClr val="tx1"/>
+          </a:fontRef>
+        </p:style>
+      </p:cxnSp>
+      <p:sp>
+        <p:nvSpPr>
+          <p:cNvPr id="20" name="Rectangle 19">
+            <a:extLst>
+              <a:ext uri="{FF2B5EF4-FFF2-40B4-BE49-F238E27FC236}">
+                <a16:creationId xmlns:a16="http://schemas.microsoft.com/office/drawing/2014/main" id="{C182B464-E139-B91D-075D-76735DFA2B38}"/>
+              </a:ext>
+            </a:extLst>
+          </p:cNvPr>
+          <p:cNvSpPr/>
+          <p:nvPr/>
+        </p:nvSpPr>
+        <p:spPr>
+          <a:xfrm>
+            <a:off x="8593724" y="2843436"/>
+            <a:ext cx="1681514" cy="718019"/>
+          </a:xfrm>
+          <a:prstGeom prst="rect">
+            <a:avLst/>
+          </a:prstGeom>
+        </p:spPr>
+        <p:style>
+          <a:lnRef idx="2">
+            <a:schemeClr val="accent3">
+              <a:shade val="15000"/>
+            </a:schemeClr>
+          </a:lnRef>
+          <a:fillRef idx="1">
+            <a:schemeClr val="accent3"/>
+          </a:fillRef>
+          <a:effectRef idx="0">
+            <a:schemeClr val="accent3"/>
+          </a:effectRef>
+          <a:fontRef idx="minor">
+            <a:schemeClr val="lt1"/>
+          </a:fontRef>
+        </p:style>
+        <p:txBody>
+          <a:bodyPr rtlCol="0" anchor="ctr"/>
+          <a:lstStyle/>
+          <a:p>
+            <a:pPr algn="ctr"/>
+            <a:r>
+              <a:rPr lang="pl-PL" dirty="0" err="1"/>
+              <a:t>dim_client</a:t>
+            </a:r>
+            <a:endParaRPr lang="pl-PL" dirty="0"/>
+          </a:p>
+        </p:txBody>
+      </p:sp>
+      <p:sp>
+        <p:nvSpPr>
+          <p:cNvPr id="23" name="Rectangle 22">
+            <a:extLst>
+              <a:ext uri="{FF2B5EF4-FFF2-40B4-BE49-F238E27FC236}">
+                <a16:creationId xmlns:a16="http://schemas.microsoft.com/office/drawing/2014/main" id="{AD3B6D5F-7F9E-3DE9-15D0-5C8534E6FDA5}"/>
+              </a:ext>
+            </a:extLst>
+          </p:cNvPr>
+          <p:cNvSpPr/>
+          <p:nvPr/>
+        </p:nvSpPr>
+        <p:spPr>
+          <a:xfrm>
+            <a:off x="5768698" y="1571050"/>
+            <a:ext cx="1007479" cy="641276"/>
+          </a:xfrm>
+          <a:prstGeom prst="rect">
+            <a:avLst/>
+          </a:prstGeom>
+        </p:spPr>
+        <p:style>
+          <a:lnRef idx="2">
+            <a:schemeClr val="accent2">
+              <a:shade val="15000"/>
+            </a:schemeClr>
+          </a:lnRef>
+          <a:fillRef idx="1">
+            <a:schemeClr val="accent2"/>
+          </a:fillRef>
+          <a:effectRef idx="0">
+            <a:schemeClr val="accent2"/>
+          </a:effectRef>
+          <a:fontRef idx="minor">
+            <a:schemeClr val="lt1"/>
+          </a:fontRef>
+        </p:style>
+        <p:txBody>
+          <a:bodyPr rtlCol="0" anchor="ctr"/>
+          <a:lstStyle/>
+          <a:p>
+            <a:pPr algn="ctr"/>
+            <a:r>
+              <a:rPr lang="pl-PL" dirty="0" err="1"/>
+              <a:t>loans</a:t>
+            </a:r>
+            <a:endParaRPr lang="pl-PL" dirty="0"/>
+          </a:p>
+        </p:txBody>
+      </p:sp>
+      <p:sp>
+        <p:nvSpPr>
+          <p:cNvPr id="24" name="Rectangle 23">
+            <a:extLst>
+              <a:ext uri="{FF2B5EF4-FFF2-40B4-BE49-F238E27FC236}">
+                <a16:creationId xmlns:a16="http://schemas.microsoft.com/office/drawing/2014/main" id="{C06C8E74-63A3-6141-1EED-81DBE253F725}"/>
+              </a:ext>
+            </a:extLst>
+          </p:cNvPr>
+          <p:cNvSpPr/>
+          <p:nvPr/>
+        </p:nvSpPr>
+        <p:spPr>
+          <a:xfrm>
+            <a:off x="3443190" y="2125929"/>
+            <a:ext cx="1223550" cy="641276"/>
+          </a:xfrm>
+          <a:prstGeom prst="rect">
+            <a:avLst/>
+          </a:prstGeom>
+        </p:spPr>
+        <p:style>
+          <a:lnRef idx="2">
+            <a:schemeClr val="accent2">
+              <a:shade val="15000"/>
+            </a:schemeClr>
+          </a:lnRef>
+          <a:fillRef idx="1">
+            <a:schemeClr val="accent2"/>
+          </a:fillRef>
+          <a:effectRef idx="0">
+            <a:schemeClr val="accent2"/>
+          </a:effectRef>
+          <a:fontRef idx="minor">
+            <a:schemeClr val="lt1"/>
+          </a:fontRef>
+        </p:style>
+        <p:txBody>
+          <a:bodyPr rtlCol="0" anchor="ctr"/>
+          <a:lstStyle/>
+          <a:p>
+            <a:pPr algn="ctr"/>
+            <a:r>
+              <a:rPr lang="pl-PL" dirty="0" err="1"/>
+              <a:t>deposits</a:t>
+            </a:r>
+            <a:endParaRPr lang="pl-PL" dirty="0"/>
+          </a:p>
+        </p:txBody>
+      </p:sp>
+      <p:sp>
+        <p:nvSpPr>
+          <p:cNvPr id="31" name="TextBox 30">
+            <a:extLst>
+              <a:ext uri="{FF2B5EF4-FFF2-40B4-BE49-F238E27FC236}">
+                <a16:creationId xmlns:a16="http://schemas.microsoft.com/office/drawing/2014/main" id="{4D55AADA-1E8F-F834-F5A0-9FA7B1BEA3A6}"/>
+              </a:ext>
+            </a:extLst>
+          </p:cNvPr>
+          <p:cNvSpPr txBox="1"/>
+          <p:nvPr/>
+        </p:nvSpPr>
+        <p:spPr>
+          <a:xfrm>
+            <a:off x="8593724" y="3761928"/>
+            <a:ext cx="1839028" cy="1754326"/>
+          </a:xfrm>
+          <a:prstGeom prst="rect">
+            <a:avLst/>
+          </a:prstGeom>
+          <a:noFill/>
+        </p:spPr>
+        <p:txBody>
+          <a:bodyPr wrap="square" rtlCol="0">
+            <a:spAutoFit/>
+          </a:bodyPr>
+          <a:lstStyle/>
+          <a:p>
+            <a:r>
+              <a:rPr lang="pl-PL" dirty="0" err="1"/>
+              <a:t>Client_id</a:t>
+            </a:r>
+            <a:endParaRPr lang="pl-PL" dirty="0"/>
+          </a:p>
+          <a:p>
+            <a:r>
+              <a:rPr lang="pl-PL" dirty="0"/>
+              <a:t>Client </a:t>
+            </a:r>
+            <a:r>
+              <a:rPr lang="pl-PL" dirty="0" err="1"/>
+              <a:t>name</a:t>
+            </a:r>
+            <a:endParaRPr lang="pl-PL" dirty="0"/>
+          </a:p>
+          <a:p>
+            <a:r>
+              <a:rPr lang="pl-PL" dirty="0"/>
+              <a:t>Client </a:t>
+            </a:r>
+            <a:r>
+              <a:rPr lang="pl-PL" dirty="0" err="1"/>
+              <a:t>surname</a:t>
+            </a:r>
+            <a:endParaRPr lang="pl-PL" dirty="0"/>
+          </a:p>
+          <a:p>
+            <a:r>
+              <a:rPr lang="pl-PL" dirty="0" err="1"/>
+              <a:t>Client_type</a:t>
+            </a:r>
+            <a:endParaRPr lang="pl-PL" dirty="0"/>
+          </a:p>
+          <a:p>
+            <a:r>
+              <a:rPr lang="pl-PL" dirty="0" err="1"/>
+              <a:t>Client_region</a:t>
+            </a:r>
+            <a:endParaRPr lang="pl-PL" dirty="0"/>
+          </a:p>
+          <a:p>
+            <a:r>
+              <a:rPr lang="pl-PL" dirty="0" err="1"/>
+              <a:t>Client_rating</a:t>
+            </a:r>
+            <a:endParaRPr lang="pl-PL" dirty="0"/>
+          </a:p>
+        </p:txBody>
+      </p:sp>
+      <p:sp>
+        <p:nvSpPr>
+          <p:cNvPr id="32" name="TextBox 31">
+            <a:extLst>
+              <a:ext uri="{FF2B5EF4-FFF2-40B4-BE49-F238E27FC236}">
+                <a16:creationId xmlns:a16="http://schemas.microsoft.com/office/drawing/2014/main" id="{6A72F712-6C4A-7C84-715F-4DC44ECFFAB9}"/>
+              </a:ext>
+            </a:extLst>
+          </p:cNvPr>
+          <p:cNvSpPr txBox="1"/>
+          <p:nvPr/>
+        </p:nvSpPr>
+        <p:spPr>
+          <a:xfrm>
+            <a:off x="1872650" y="2024417"/>
+            <a:ext cx="1527069" cy="646331"/>
+          </a:xfrm>
+          <a:prstGeom prst="rect">
+            <a:avLst/>
+          </a:prstGeom>
+          <a:noFill/>
+        </p:spPr>
+        <p:txBody>
+          <a:bodyPr wrap="square" rtlCol="0">
+            <a:spAutoFit/>
+          </a:bodyPr>
+          <a:lstStyle/>
+          <a:p>
+            <a:r>
+              <a:rPr lang="pl-PL" dirty="0"/>
+              <a:t>SA, CA, </a:t>
+            </a:r>
+            <a:r>
+              <a:rPr lang="pl-PL" dirty="0" err="1"/>
+              <a:t>term_depo</a:t>
+            </a:r>
+            <a:endParaRPr lang="pl-PL" dirty="0"/>
+          </a:p>
+        </p:txBody>
+      </p:sp>
+      <p:sp>
+        <p:nvSpPr>
+          <p:cNvPr id="33" name="TextBox 32">
+            <a:extLst>
+              <a:ext uri="{FF2B5EF4-FFF2-40B4-BE49-F238E27FC236}">
+                <a16:creationId xmlns:a16="http://schemas.microsoft.com/office/drawing/2014/main" id="{16143FAE-0891-1E3D-CAD9-19E223E12349}"/>
+              </a:ext>
+            </a:extLst>
+          </p:cNvPr>
+          <p:cNvSpPr txBox="1"/>
+          <p:nvPr/>
+        </p:nvSpPr>
+        <p:spPr>
+          <a:xfrm>
+            <a:off x="6806862" y="1320235"/>
+            <a:ext cx="2044618" cy="646331"/>
+          </a:xfrm>
+          <a:prstGeom prst="rect">
+            <a:avLst/>
+          </a:prstGeom>
+          <a:noFill/>
+        </p:spPr>
+        <p:txBody>
+          <a:bodyPr wrap="square" rtlCol="0">
+            <a:spAutoFit/>
+          </a:bodyPr>
+          <a:lstStyle/>
+          <a:p>
+            <a:r>
+              <a:rPr lang="pl-PL" dirty="0" err="1"/>
+              <a:t>Mortgages</a:t>
+            </a:r>
+            <a:r>
+              <a:rPr lang="pl-PL" dirty="0"/>
+              <a:t>, </a:t>
+            </a:r>
+            <a:r>
+              <a:rPr lang="pl-PL" dirty="0" err="1"/>
+              <a:t>cash</a:t>
+            </a:r>
+            <a:r>
+              <a:rPr lang="pl-PL" dirty="0"/>
+              <a:t> </a:t>
+            </a:r>
+            <a:r>
+              <a:rPr lang="pl-PL" dirty="0" err="1"/>
+              <a:t>loans</a:t>
+            </a:r>
+            <a:endParaRPr lang="pl-PL" dirty="0"/>
+          </a:p>
+        </p:txBody>
+      </p:sp>
+      <p:sp>
+        <p:nvSpPr>
+          <p:cNvPr id="39" name="Rectangle 38">
+            <a:extLst>
+              <a:ext uri="{FF2B5EF4-FFF2-40B4-BE49-F238E27FC236}">
+                <a16:creationId xmlns:a16="http://schemas.microsoft.com/office/drawing/2014/main" id="{2E136DB9-ACB3-4846-2845-FE563D55AEB0}"/>
+              </a:ext>
+            </a:extLst>
+          </p:cNvPr>
+          <p:cNvSpPr/>
+          <p:nvPr/>
+        </p:nvSpPr>
+        <p:spPr>
+          <a:xfrm>
+            <a:off x="6621250" y="5016958"/>
+            <a:ext cx="1891130" cy="859168"/>
+          </a:xfrm>
+          <a:prstGeom prst="rect">
+            <a:avLst/>
+          </a:prstGeom>
+        </p:spPr>
+        <p:style>
+          <a:lnRef idx="2">
+            <a:schemeClr val="accent2">
+              <a:shade val="15000"/>
+            </a:schemeClr>
+          </a:lnRef>
+          <a:fillRef idx="1">
+            <a:schemeClr val="accent2"/>
+          </a:fillRef>
+          <a:effectRef idx="0">
+            <a:schemeClr val="accent2"/>
+          </a:effectRef>
+          <a:fontRef idx="minor">
+            <a:schemeClr val="lt1"/>
+          </a:fontRef>
+        </p:style>
+        <p:txBody>
+          <a:bodyPr rtlCol="0" anchor="ctr"/>
+          <a:lstStyle/>
+          <a:p>
+            <a:pPr algn="ctr"/>
+            <a:r>
+              <a:rPr lang="pl-PL" dirty="0" err="1"/>
+              <a:t>Financal_instruments</a:t>
+            </a:r>
+            <a:endParaRPr lang="pl-PL" dirty="0"/>
+          </a:p>
+        </p:txBody>
+      </p:sp>
+      <p:sp>
+        <p:nvSpPr>
+          <p:cNvPr id="41" name="TextBox 40">
+            <a:extLst>
+              <a:ext uri="{FF2B5EF4-FFF2-40B4-BE49-F238E27FC236}">
+                <a16:creationId xmlns:a16="http://schemas.microsoft.com/office/drawing/2014/main" id="{BC9B0BCD-2C1A-027A-7268-34BDB0A96090}"/>
+              </a:ext>
+            </a:extLst>
+          </p:cNvPr>
+          <p:cNvSpPr txBox="1"/>
+          <p:nvPr/>
+        </p:nvSpPr>
+        <p:spPr>
+          <a:xfrm>
+            <a:off x="3259181" y="5454757"/>
+            <a:ext cx="1839028" cy="369332"/>
+          </a:xfrm>
+          <a:prstGeom prst="rect">
+            <a:avLst/>
+          </a:prstGeom>
+          <a:noFill/>
+        </p:spPr>
+        <p:txBody>
+          <a:bodyPr wrap="square" rtlCol="0">
+            <a:spAutoFit/>
+          </a:bodyPr>
+          <a:lstStyle/>
+          <a:p>
+            <a:r>
+              <a:rPr lang="pl-PL" dirty="0"/>
+              <a:t>IRS </a:t>
+            </a:r>
+          </a:p>
+        </p:txBody>
+      </p:sp>
+      <p:sp>
+        <p:nvSpPr>
+          <p:cNvPr id="42" name="Rectangle 41">
+            <a:extLst>
+              <a:ext uri="{FF2B5EF4-FFF2-40B4-BE49-F238E27FC236}">
+                <a16:creationId xmlns:a16="http://schemas.microsoft.com/office/drawing/2014/main" id="{20025CDF-360A-4BCC-238B-BB9E27722F67}"/>
+              </a:ext>
+            </a:extLst>
+          </p:cNvPr>
+          <p:cNvSpPr/>
+          <p:nvPr/>
+        </p:nvSpPr>
+        <p:spPr>
+          <a:xfrm>
+            <a:off x="2701807" y="4457152"/>
+            <a:ext cx="1891130" cy="859168"/>
+          </a:xfrm>
+          <a:prstGeom prst="rect">
+            <a:avLst/>
+          </a:prstGeom>
+        </p:spPr>
+        <p:style>
+          <a:lnRef idx="2">
+            <a:schemeClr val="accent2">
+              <a:shade val="15000"/>
+            </a:schemeClr>
+          </a:lnRef>
+          <a:fillRef idx="1">
+            <a:schemeClr val="accent2"/>
+          </a:fillRef>
+          <a:effectRef idx="0">
+            <a:schemeClr val="accent2"/>
+          </a:effectRef>
+          <a:fontRef idx="minor">
+            <a:schemeClr val="lt1"/>
+          </a:fontRef>
+        </p:style>
+        <p:txBody>
+          <a:bodyPr rtlCol="0" anchor="ctr"/>
+          <a:lstStyle/>
+          <a:p>
+            <a:pPr algn="ctr"/>
+            <a:r>
+              <a:rPr lang="pl-PL" dirty="0" err="1"/>
+              <a:t>derivatives</a:t>
+            </a:r>
+            <a:endParaRPr lang="pl-PL" dirty="0"/>
+          </a:p>
+        </p:txBody>
+      </p:sp>
+      <p:cxnSp>
+        <p:nvCxnSpPr>
+          <p:cNvPr id="43" name="Straight Arrow Connector 42">
+            <a:extLst>
+              <a:ext uri="{FF2B5EF4-FFF2-40B4-BE49-F238E27FC236}">
+                <a16:creationId xmlns:a16="http://schemas.microsoft.com/office/drawing/2014/main" id="{ADEFAD39-305A-0FA1-EFF2-4FE384F99858}"/>
+              </a:ext>
+            </a:extLst>
+          </p:cNvPr>
+          <p:cNvCxnSpPr>
+            <a:cxnSpLocks/>
+            <a:stCxn id="4" idx="1"/>
+            <a:endCxn id="42" idx="0"/>
+          </p:cNvCxnSpPr>
+          <p:nvPr/>
+        </p:nvCxnSpPr>
+        <p:spPr>
+          <a:xfrm flipH="1">
+            <a:off x="3647372" y="3353823"/>
+            <a:ext cx="1759248" cy="1103329"/>
+          </a:xfrm>
+          <a:prstGeom prst="straightConnector1">
+            <a:avLst/>
+          </a:prstGeom>
+          <a:ln>
+            <a:tailEnd type="triangle"/>
+          </a:ln>
+        </p:spPr>
+        <p:style>
+          <a:lnRef idx="2">
+            <a:schemeClr val="accent1"/>
+          </a:lnRef>
+          <a:fillRef idx="0">
+            <a:schemeClr val="accent1"/>
+          </a:fillRef>
+          <a:effectRef idx="1">
+            <a:schemeClr val="accent1"/>
+          </a:effectRef>
+          <a:fontRef idx="minor">
+            <a:schemeClr val="tx1"/>
+          </a:fontRef>
+        </p:style>
+      </p:cxnSp>
+      <p:sp>
+        <p:nvSpPr>
+          <p:cNvPr id="45" name="TextBox 44">
+            <a:extLst>
+              <a:ext uri="{FF2B5EF4-FFF2-40B4-BE49-F238E27FC236}">
+                <a16:creationId xmlns:a16="http://schemas.microsoft.com/office/drawing/2014/main" id="{1A3B467C-DC13-7C90-BDC8-5C6544D45E30}"/>
+              </a:ext>
+            </a:extLst>
+          </p:cNvPr>
+          <p:cNvSpPr txBox="1"/>
+          <p:nvPr/>
+        </p:nvSpPr>
+        <p:spPr>
+          <a:xfrm>
+            <a:off x="7058473" y="6028526"/>
+            <a:ext cx="1839028" cy="369332"/>
+          </a:xfrm>
+          <a:prstGeom prst="rect">
+            <a:avLst/>
+          </a:prstGeom>
+          <a:noFill/>
+        </p:spPr>
+        <p:txBody>
+          <a:bodyPr wrap="square" rtlCol="0">
+            <a:spAutoFit/>
+          </a:bodyPr>
+          <a:lstStyle/>
+          <a:p>
+            <a:r>
+              <a:rPr lang="pl-PL" dirty="0" err="1"/>
+              <a:t>Bonds</a:t>
+            </a:r>
+            <a:endParaRPr lang="pl-PL" dirty="0"/>
+          </a:p>
+        </p:txBody>
+      </p:sp>
+      <p:sp>
+        <p:nvSpPr>
+          <p:cNvPr id="46" name="Rectangle 45">
+            <a:extLst>
+              <a:ext uri="{FF2B5EF4-FFF2-40B4-BE49-F238E27FC236}">
+                <a16:creationId xmlns:a16="http://schemas.microsoft.com/office/drawing/2014/main" id="{4B553589-AA26-BC93-3416-E2F2AB7C5849}"/>
+              </a:ext>
+            </a:extLst>
+          </p:cNvPr>
+          <p:cNvSpPr/>
+          <p:nvPr/>
+        </p:nvSpPr>
+        <p:spPr>
+          <a:xfrm>
+            <a:off x="9319925" y="1328179"/>
+            <a:ext cx="1891130" cy="859168"/>
+          </a:xfrm>
+          <a:prstGeom prst="rect">
+            <a:avLst/>
+          </a:prstGeom>
+        </p:spPr>
+        <p:style>
+          <a:lnRef idx="2">
+            <a:schemeClr val="accent2">
+              <a:shade val="15000"/>
+            </a:schemeClr>
+          </a:lnRef>
+          <a:fillRef idx="1">
+            <a:schemeClr val="accent2"/>
+          </a:fillRef>
+          <a:effectRef idx="0">
+            <a:schemeClr val="accent2"/>
+          </a:effectRef>
+          <a:fontRef idx="minor">
+            <a:schemeClr val="lt1"/>
+          </a:fontRef>
+        </p:style>
+        <p:txBody>
+          <a:bodyPr rtlCol="0" anchor="ctr"/>
+          <a:lstStyle/>
+          <a:p>
+            <a:pPr algn="ctr"/>
+            <a:r>
+              <a:rPr lang="pl-PL" dirty="0"/>
+              <a:t>equity</a:t>
+            </a:r>
+          </a:p>
+        </p:txBody>
+      </p:sp>
+      <p:cxnSp>
+        <p:nvCxnSpPr>
+          <p:cNvPr id="47" name="Straight Arrow Connector 46">
+            <a:extLst>
+              <a:ext uri="{FF2B5EF4-FFF2-40B4-BE49-F238E27FC236}">
+                <a16:creationId xmlns:a16="http://schemas.microsoft.com/office/drawing/2014/main" id="{55106EB1-57EA-3EDE-4EB2-71555E035098}"/>
+              </a:ext>
+            </a:extLst>
+          </p:cNvPr>
+          <p:cNvCxnSpPr>
+            <a:cxnSpLocks/>
+            <a:endCxn id="46" idx="2"/>
+          </p:cNvCxnSpPr>
+          <p:nvPr/>
+        </p:nvCxnSpPr>
+        <p:spPr>
+          <a:xfrm flipV="1">
+            <a:off x="7088135" y="2187347"/>
+            <a:ext cx="3177355" cy="933161"/>
+          </a:xfrm>
+          <a:prstGeom prst="straightConnector1">
+            <a:avLst/>
+          </a:prstGeom>
+          <a:ln>
+            <a:tailEnd type="triangle"/>
+          </a:ln>
+        </p:spPr>
+        <p:style>
+          <a:lnRef idx="2">
+            <a:schemeClr val="accent1"/>
+          </a:lnRef>
+          <a:fillRef idx="0">
+            <a:schemeClr val="accent1"/>
+          </a:fillRef>
+          <a:effectRef idx="1">
+            <a:schemeClr val="accent1"/>
+          </a:effectRef>
+          <a:fontRef idx="minor">
+            <a:schemeClr val="tx1"/>
+          </a:fontRef>
+        </p:style>
+      </p:cxnSp>
+      <p:sp>
+        <p:nvSpPr>
+          <p:cNvPr id="9" name="TextBox 8">
+            <a:extLst>
+              <a:ext uri="{FF2B5EF4-FFF2-40B4-BE49-F238E27FC236}">
+                <a16:creationId xmlns:a16="http://schemas.microsoft.com/office/drawing/2014/main" id="{2931D084-1643-0FD1-81FA-4A06A2151194}"/>
+              </a:ext>
+            </a:extLst>
+          </p:cNvPr>
+          <p:cNvSpPr txBox="1"/>
+          <p:nvPr/>
+        </p:nvSpPr>
+        <p:spPr>
+          <a:xfrm>
+            <a:off x="10319350" y="2347582"/>
+            <a:ext cx="1839028" cy="1200329"/>
+          </a:xfrm>
+          <a:prstGeom prst="rect">
+            <a:avLst/>
+          </a:prstGeom>
+          <a:noFill/>
+        </p:spPr>
+        <p:txBody>
+          <a:bodyPr wrap="square" rtlCol="0">
+            <a:spAutoFit/>
+          </a:bodyPr>
+          <a:lstStyle/>
+          <a:p>
+            <a:r>
+              <a:rPr lang="pl-PL" dirty="0" err="1"/>
+              <a:t>Issued</a:t>
+            </a:r>
+            <a:r>
+              <a:rPr lang="pl-PL" dirty="0"/>
+              <a:t> </a:t>
+            </a:r>
+            <a:r>
+              <a:rPr lang="pl-PL" dirty="0" err="1"/>
+              <a:t>bonds</a:t>
+            </a:r>
+            <a:r>
+              <a:rPr lang="pl-PL" dirty="0"/>
+              <a:t>, </a:t>
+            </a:r>
+            <a:r>
+              <a:rPr lang="pl-PL" dirty="0" err="1"/>
+              <a:t>Issued</a:t>
+            </a:r>
+            <a:r>
+              <a:rPr lang="pl-PL" dirty="0"/>
+              <a:t> </a:t>
+            </a:r>
+            <a:r>
+              <a:rPr lang="pl-PL" dirty="0" err="1"/>
+              <a:t>stocks</a:t>
+            </a:r>
+            <a:r>
+              <a:rPr lang="pl-PL" dirty="0"/>
+              <a:t>, </a:t>
+            </a:r>
+            <a:r>
+              <a:rPr lang="pl-PL" dirty="0" err="1"/>
+              <a:t>retained</a:t>
+            </a:r>
+            <a:r>
+              <a:rPr lang="pl-PL" dirty="0"/>
+              <a:t> </a:t>
+            </a:r>
+            <a:r>
+              <a:rPr lang="pl-PL" dirty="0" err="1"/>
+              <a:t>earnings</a:t>
+            </a:r>
+            <a:endParaRPr lang="pl-PL" dirty="0"/>
+          </a:p>
+        </p:txBody>
+      </p:sp>
+    </p:spTree>
+    <p:extLst>
+      <p:ext uri="{BB962C8B-B14F-4D97-AF65-F5344CB8AC3E}">
+        <p14:creationId xmlns:p14="http://schemas.microsoft.com/office/powerpoint/2010/main" val="2022600030"/>
       </p:ext>
     </p:extLst>
   </p:cSld>

</xml_diff>